<commit_message>
Rebuild final report with diagrams, charts, screenshots and code excerpts
Final report now includes architecture, use-case, DFD, class, sequence and
flowchart diagrams, dashboard analytics charts, app screenshots, real test
results, and auto-numbered lists of figures and tables. Report generation
moved into tools/report_builder.py.
</commit_message>
<xml_diff>
--- a/Documentation/PPT/InventoryManagementSystem.pptx
+++ b/Documentation/PPT/InventoryManagementSystem.pptx
@@ -898,10 +898,10 @@
                 <c:formatCode>General</c:formatCode>
                 <c:ptCount val="2"/>
                 <c:pt idx="0">
-                  <c:v>18</c:v>
+                  <c:v>19</c:v>
                 </c:pt>
                 <c:pt idx="1">
-                  <c:v>4</c:v>
+                  <c:v>3</c:v>
                 </c:pt>
               </c:numCache>
             </c:numRef>
@@ -1765,7 +1765,7 @@
           <a:lstStyle/>
           <a:p>
             <a:r>
-              <a:t>We ran 22 test cases covering build, authentication, stock validation, reporting and the PWA API layer. 18 passed automated verification via curl and sqlcmd checks against the live app and database; the remainder are flagged for manual browser-based verification, like the install prompt and offline reload. This table highlights six of the most important cases, including the insufficient-stock guard we just demonstrated.</a:t>
+              <a:t>We ran 22 test cases covering build, authentication, stock validation, reporting and the PWA API layer. 19 passed automated verification via curl and sqlcmd checks against the live app and database; the remainder are flagged for manual browser-based verification, like the install prompt and offline reload. This table highlights six of the most important cases, including the insufficient-stock guard we just demonstrated.</a:t>
             </a:r>
           </a:p>
         </p:txBody>
@@ -7386,8 +7386,8 @@
         </p:nvSpPr>
         <p:spPr>
           <a:xfrm>
-            <a:off x="6812280" y="2472370"/>
-            <a:ext cx="4876495" cy="2736218"/>
+            <a:off x="6812280" y="2524358"/>
+            <a:ext cx="4876495" cy="2632243"/>
           </a:xfrm>
           <a:prstGeom prst="roundRect">
             <a:avLst>
@@ -7446,8 +7446,8 @@
         </p:blipFill>
         <p:spPr>
           <a:xfrm>
-            <a:off x="6885432" y="2545522"/>
-            <a:ext cx="4730191" cy="2589914"/>
+            <a:off x="6885432" y="2597510"/>
+            <a:ext cx="4730191" cy="2485939"/>
           </a:xfrm>
           <a:prstGeom prst="rect">
             <a:avLst/>
@@ -8730,8 +8730,8 @@
         </p:nvSpPr>
         <p:spPr>
           <a:xfrm>
-            <a:off x="8192315" y="4114800"/>
-            <a:ext cx="2427320" cy="2011680"/>
+            <a:off x="8064200" y="4114800"/>
+            <a:ext cx="2683549" cy="2011680"/>
           </a:xfrm>
           <a:prstGeom prst="roundRect">
             <a:avLst>
@@ -8790,8 +8790,8 @@
         </p:blipFill>
         <p:spPr>
           <a:xfrm>
-            <a:off x="8265467" y="4187952"/>
-            <a:ext cx="2281016" cy="1865376"/>
+            <a:off x="8137352" y="4187952"/>
+            <a:ext cx="2537245" cy="1865376"/>
           </a:xfrm>
           <a:prstGeom prst="rect">
             <a:avLst/>
@@ -9080,7 +9080,7 @@
                 </a:solidFill>
                 <a:latin typeface="Segoe UI"/>
               </a:rPr>
-              <a:t>18/22</a:t>
+              <a:t>19/22</a:t>
             </a:r>
           </a:p>
         </p:txBody>
@@ -15173,8 +15173,8 @@
         </p:nvSpPr>
         <p:spPr>
           <a:xfrm>
-            <a:off x="6675120" y="1966120"/>
-            <a:ext cx="5013655" cy="3657278"/>
+            <a:off x="6675120" y="1860517"/>
+            <a:ext cx="5013655" cy="3868484"/>
           </a:xfrm>
           <a:prstGeom prst="roundRect">
             <a:avLst>
@@ -15233,8 +15233,8 @@
         </p:blipFill>
         <p:spPr>
           <a:xfrm>
-            <a:off x="6748272" y="2039272"/>
-            <a:ext cx="4867351" cy="3510974"/>
+            <a:off x="6748272" y="1933669"/>
+            <a:ext cx="4867351" cy="3722180"/>
           </a:xfrm>
           <a:prstGeom prst="rect">
             <a:avLst/>

</xml_diff>